<commit_message>
Fix a table/heading collision on the SHAP slide
Checked the added slides geometrically since no renderer is available here to
look at them. All shapes sit inside the slide (the two off-canvas shapes are the
original title slide's decorative circles, which bleed by design), but slide
18's seven-row table ended at 4.43in against a heading at 4.35in. Row height
trimmed to 0.32in; all seven result tables now clear the content beneath them.

Also verified the report renders clean: 12 pages, no text block crossing a
margin on any of them.
</commit_message>
<xml_diff>
--- a/bias_mitigation_plan.pptx
+++ b/bias_mitigation_plan.pptx
@@ -9230,7 +9230,7 @@
         </p:nvGraphicFramePr>
         <p:xfrm>
           <a:off x="640080" y="1691640"/>
-          <a:ext cx="10881360" cy="2359152"/>
+          <a:ext cx="10881360" cy="2139696"/>
         </p:xfrm>
         <a:graphic>
           <a:graphicData uri="http://schemas.openxmlformats.org/drawingml/2006/table">
@@ -9338,7 +9338,7 @@
                   </a:tcPr>
                 </a:tc>
               </a:tr>
-              <a:tr h="329184">
+              <a:tr h="292608">
                 <a:tc>
                   <a:txBody>
                     <a:bodyPr wrap="square"/>
@@ -9432,7 +9432,7 @@
                   </a:tcPr>
                 </a:tc>
               </a:tr>
-              <a:tr h="329184">
+              <a:tr h="292608">
                 <a:tc>
                   <a:txBody>
                     <a:bodyPr wrap="square"/>
@@ -9526,7 +9526,7 @@
                   </a:tcPr>
                 </a:tc>
               </a:tr>
-              <a:tr h="329184">
+              <a:tr h="292608">
                 <a:tc>
                   <a:txBody>
                     <a:bodyPr wrap="square"/>
@@ -9620,7 +9620,7 @@
                   </a:tcPr>
                 </a:tc>
               </a:tr>
-              <a:tr h="329184">
+              <a:tr h="292608">
                 <a:tc>
                   <a:txBody>
                     <a:bodyPr wrap="square"/>
@@ -9714,7 +9714,7 @@
                   </a:tcPr>
                 </a:tc>
               </a:tr>
-              <a:tr h="329184">
+              <a:tr h="292608">
                 <a:tc>
                   <a:txBody>
                     <a:bodyPr wrap="square"/>
@@ -9808,7 +9808,7 @@
                   </a:tcPr>
                 </a:tc>
               </a:tr>
-              <a:tr h="329184">
+              <a:tr h="292608">
                 <a:tc>
                   <a:txBody>
                     <a:bodyPr wrap="square"/>

</xml_diff>

<commit_message>
Rebuild the report and deck so they stop claiming novelty the sources no longer claim
Both artefacts are generated from scripts/build_*.py, whose contribution lists called the
incidence and intersectional analyses "(new)". They are not new -- Ferry et al. (2023)
published the decomposition and Kearns (2018) named the intersectional failure mode -- and
the sources were corrected in the previous commit. Until now the built PDF and PPTX still
said the old thing.

No number, table or figure changes; test_documented_claims checks the course figures and
passes identically before and after. What changes is two "(new)" labels, three citations,
and a reference-list entry.
</commit_message>
<xml_diff>
--- a/bias_mitigation_plan.pptx
+++ b/bias_mitigation_plan.pptx
@@ -8790,7 +8790,7 @@
                 </a:solidFill>
                 <a:latin typeface="Calibri"/>
               </a:rPr>
-              <a:t>Not in the plan. A gap can close by lifting one group or lowering the other. The metric is identical either way.</a:t>
+              <a:t>Not in the plan. A gap can close by lifting one group or lowering the other — the metric is identical either way. That is Ferry et al.'s (2023) starting point; the measurement is ours.</a:t>
             </a:r>
           </a:p>
         </p:txBody>
@@ -10261,7 +10261,7 @@
                 </a:solidFill>
                 <a:latin typeface="Calibri"/>
               </a:rPr>
-              <a:t>Every method so far constrains one binary attribute. That is the field's default, and it has a blind spot.</a:t>
+              <a:t>Every method so far constrains one binary attribute. That is the field's default, and it has a named blind spot (Kearns et al. 2018) that overall performance figures do not show (Maheshwari et al. 2023).</a:t>
             </a:r>
           </a:p>
         </p:txBody>

</xml_diff>